<commit_message>
Create professional enterprise RHOAI presentation with visual diagrams
- NEW: Enterprise_AI_Platform_RHOAI.pptx (10 slides, widescreen 16:9)
- Focus: Red Hat OpenShift AI 3.5 enterprise capabilities (not implementation)
- Visual diagrams instead of text/ASCII
- Slides: RHOAI Platform, Components, Infrastructure, MaaS, Security, Observability, GitOps, Stack, Value
- Red Hat brand colors and modern styling
- Less text, more visuals

Co-Authored-By: Claude Sonnet 4.5 <noreply@anthropic.com>
</commit_message>
<xml_diff>
--- a/docs/ppts/ISO_Compliance_AI_Platform_Final_Project.pptx
+++ b/docs/ppts/ISO_Compliance_AI_Platform_Final_Project.pptx
@@ -5,18 +5,18 @@
     <p:sldMasterId id="2147483648" r:id="rId1"/>
   </p:sldMasterIdLst>
   <p:sldIdLst>
-    <p:sldId id="256" r:id="rId7"/>
-    <p:sldId id="257" r:id="rId8"/>
-    <p:sldId id="258" r:id="rId9"/>
-    <p:sldId id="259" r:id="rId10"/>
-    <p:sldId id="260" r:id="rId11"/>
-    <p:sldId id="261" r:id="rId12"/>
-    <p:sldId id="262" r:id="rId13"/>
-    <p:sldId id="263" r:id="rId14"/>
-    <p:sldId id="264" r:id="rId15"/>
-    <p:sldId id="265" r:id="rId16"/>
+    <p:sldId id="256" r:id="rId2"/>
+    <p:sldId id="257" r:id="rId3"/>
+    <p:sldId id="258" r:id="rId4"/>
+    <p:sldId id="259" r:id="rId5"/>
+    <p:sldId id="260" r:id="rId6"/>
+    <p:sldId id="261" r:id="rId7"/>
+    <p:sldId id="262" r:id="rId8"/>
+    <p:sldId id="263" r:id="rId9"/>
+    <p:sldId id="264" r:id="rId10"/>
+    <p:sldId id="265" r:id="rId11"/>
   </p:sldIdLst>
-  <p:sldSz cx="9144000" cy="6858000" type="screen4x3"/>
+  <p:sldSz cx="12192000" cy="6858000"/>
   <p:notesSz cx="6858000" cy="9144000"/>
   <p:defaultTextStyle>
     <a:defPPr>
@@ -113,6 +113,22 @@
       </a:defRPr>
     </a:lvl9pPr>
   </p:defaultTextStyle>
+  <p:extLst>
+    <p:ext uri="{EFAFB233-063F-42B5-8137-9DF3F51BA10A}">
+      <p15:sldGuideLst xmlns:p15="http://schemas.microsoft.com/office/powerpoint/2012/main">
+        <p15:guide id="1" orient="horz" pos="2160" userDrawn="1">
+          <p15:clr>
+            <a:srgbClr val="A4A3A4"/>
+          </p15:clr>
+        </p15:guide>
+        <p15:guide id="2" pos="3840" userDrawn="1">
+          <p15:clr>
+            <a:srgbClr val="A4A3A4"/>
+          </p15:clr>
+        </p15:guide>
+      </p15:sldGuideLst>
+    </p:ext>
+  </p:extLst>
 </p:presentation>
 </file>
 
@@ -145,8 +161,8 @@
         </p:nvSpPr>
         <p:spPr>
           <a:xfrm>
-            <a:off x="685800" y="2130425"/>
-            <a:ext cx="7772400" cy="1470025"/>
+            <a:off x="914400" y="2130426"/>
+            <a:ext cx="10363200" cy="1470025"/>
           </a:xfrm>
         </p:spPr>
         <p:txBody>
@@ -154,10 +170,9 @@
           <a:lstStyle/>
           <a:p>
             <a:r>
-              <a:rPr lang="en-US" smtClean="0"/>
+              <a:rPr lang="en-US"/>
               <a:t>Click to edit Master title style</a:t>
             </a:r>
-            <a:endParaRPr lang="en-US"/>
           </a:p>
         </p:txBody>
       </p:sp>
@@ -173,8 +188,8 @@
         </p:nvSpPr>
         <p:spPr>
           <a:xfrm>
-            <a:off x="1371600" y="3886200"/>
-            <a:ext cx="6400800" cy="1752600"/>
+            <a:off x="1828800" y="3886200"/>
+            <a:ext cx="8534400" cy="1752600"/>
           </a:xfrm>
         </p:spPr>
         <p:txBody>
@@ -273,10 +288,9 @@
           </a:lstStyle>
           <a:p>
             <a:r>
-              <a:rPr lang="en-US" smtClean="0"/>
+              <a:rPr lang="en-US"/>
               <a:t>Click to edit Master subtitle style</a:t>
             </a:r>
-            <a:endParaRPr lang="en-US"/>
           </a:p>
         </p:txBody>
       </p:sp>
@@ -297,7 +311,7 @@
           <a:p>
             <a:fld id="{5BCAD085-E8A6-8845-BD4E-CB4CCA059FC4}" type="datetimeFigureOut">
               <a:rPr lang="en-US" smtClean="0"/>
-              <a:t>1/27/13</a:t>
+              <a:t>7/24/26</a:t>
             </a:fld>
             <a:endParaRPr lang="en-US"/>
           </a:p>
@@ -391,10 +405,9 @@
           <a:lstStyle/>
           <a:p>
             <a:r>
-              <a:rPr lang="en-US" smtClean="0"/>
+              <a:rPr lang="en-US"/>
               <a:t>Click to edit Master title style</a:t>
             </a:r>
-            <a:endParaRPr lang="en-US"/>
           </a:p>
         </p:txBody>
       </p:sp>
@@ -415,38 +428,37 @@
           <a:p>
             <a:pPr lvl="0"/>
             <a:r>
-              <a:rPr lang="en-US" smtClean="0"/>
+              <a:rPr lang="en-US"/>
               <a:t>Click to edit Master text styles</a:t>
             </a:r>
           </a:p>
           <a:p>
             <a:pPr lvl="1"/>
             <a:r>
-              <a:rPr lang="en-US" smtClean="0"/>
+              <a:rPr lang="en-US"/>
               <a:t>Second level</a:t>
             </a:r>
           </a:p>
           <a:p>
             <a:pPr lvl="2"/>
             <a:r>
-              <a:rPr lang="en-US" smtClean="0"/>
+              <a:rPr lang="en-US"/>
               <a:t>Third level</a:t>
             </a:r>
           </a:p>
           <a:p>
             <a:pPr lvl="3"/>
             <a:r>
-              <a:rPr lang="en-US" smtClean="0"/>
+              <a:rPr lang="en-US"/>
               <a:t>Fourth level</a:t>
             </a:r>
           </a:p>
           <a:p>
             <a:pPr lvl="4"/>
             <a:r>
-              <a:rPr lang="en-US" smtClean="0"/>
+              <a:rPr lang="en-US"/>
               <a:t>Fifth level</a:t>
             </a:r>
-            <a:endParaRPr lang="en-US"/>
           </a:p>
         </p:txBody>
       </p:sp>
@@ -467,7 +479,7 @@
           <a:p>
             <a:fld id="{5BCAD085-E8A6-8845-BD4E-CB4CCA059FC4}" type="datetimeFigureOut">
               <a:rPr lang="en-US" smtClean="0"/>
-              <a:t>1/27/13</a:t>
+              <a:t>7/24/26</a:t>
             </a:fld>
             <a:endParaRPr lang="en-US"/>
           </a:p>
@@ -557,8 +569,8 @@
         </p:nvSpPr>
         <p:spPr>
           <a:xfrm>
-            <a:off x="6629400" y="274638"/>
-            <a:ext cx="2057400" cy="5851525"/>
+            <a:off x="8839200" y="274639"/>
+            <a:ext cx="2743200" cy="5851525"/>
           </a:xfrm>
         </p:spPr>
         <p:txBody>
@@ -566,10 +578,9 @@
           <a:lstStyle/>
           <a:p>
             <a:r>
-              <a:rPr lang="en-US" smtClean="0"/>
+              <a:rPr lang="en-US"/>
               <a:t>Click to edit Master title style</a:t>
             </a:r>
-            <a:endParaRPr lang="en-US"/>
           </a:p>
         </p:txBody>
       </p:sp>
@@ -585,8 +596,8 @@
         </p:nvSpPr>
         <p:spPr>
           <a:xfrm>
-            <a:off x="457200" y="274638"/>
-            <a:ext cx="6019800" cy="5851525"/>
+            <a:off x="609600" y="274639"/>
+            <a:ext cx="8026400" cy="5851525"/>
           </a:xfrm>
         </p:spPr>
         <p:txBody>
@@ -595,38 +606,37 @@
           <a:p>
             <a:pPr lvl="0"/>
             <a:r>
-              <a:rPr lang="en-US" smtClean="0"/>
+              <a:rPr lang="en-US"/>
               <a:t>Click to edit Master text styles</a:t>
             </a:r>
           </a:p>
           <a:p>
             <a:pPr lvl="1"/>
             <a:r>
-              <a:rPr lang="en-US" smtClean="0"/>
+              <a:rPr lang="en-US"/>
               <a:t>Second level</a:t>
             </a:r>
           </a:p>
           <a:p>
             <a:pPr lvl="2"/>
             <a:r>
-              <a:rPr lang="en-US" smtClean="0"/>
+              <a:rPr lang="en-US"/>
               <a:t>Third level</a:t>
             </a:r>
           </a:p>
           <a:p>
             <a:pPr lvl="3"/>
             <a:r>
-              <a:rPr lang="en-US" smtClean="0"/>
+              <a:rPr lang="en-US"/>
               <a:t>Fourth level</a:t>
             </a:r>
           </a:p>
           <a:p>
             <a:pPr lvl="4"/>
             <a:r>
-              <a:rPr lang="en-US" smtClean="0"/>
+              <a:rPr lang="en-US"/>
               <a:t>Fifth level</a:t>
             </a:r>
-            <a:endParaRPr lang="en-US"/>
           </a:p>
         </p:txBody>
       </p:sp>
@@ -647,7 +657,7 @@
           <a:p>
             <a:fld id="{5BCAD085-E8A6-8845-BD4E-CB4CCA059FC4}" type="datetimeFigureOut">
               <a:rPr lang="en-US" smtClean="0"/>
-              <a:t>1/27/13</a:t>
+              <a:t>7/24/26</a:t>
             </a:fld>
             <a:endParaRPr lang="en-US"/>
           </a:p>
@@ -741,10 +751,9 @@
           <a:lstStyle/>
           <a:p>
             <a:r>
-              <a:rPr lang="en-US" smtClean="0"/>
+              <a:rPr lang="en-US"/>
               <a:t>Click to edit Master title style</a:t>
             </a:r>
-            <a:endParaRPr lang="en-US"/>
           </a:p>
         </p:txBody>
       </p:sp>
@@ -765,38 +774,37 @@
           <a:p>
             <a:pPr lvl="0"/>
             <a:r>
-              <a:rPr lang="en-US" smtClean="0"/>
+              <a:rPr lang="en-US"/>
               <a:t>Click to edit Master text styles</a:t>
             </a:r>
           </a:p>
           <a:p>
             <a:pPr lvl="1"/>
             <a:r>
-              <a:rPr lang="en-US" smtClean="0"/>
+              <a:rPr lang="en-US"/>
               <a:t>Second level</a:t>
             </a:r>
           </a:p>
           <a:p>
             <a:pPr lvl="2"/>
             <a:r>
-              <a:rPr lang="en-US" smtClean="0"/>
+              <a:rPr lang="en-US"/>
               <a:t>Third level</a:t>
             </a:r>
           </a:p>
           <a:p>
             <a:pPr lvl="3"/>
             <a:r>
-              <a:rPr lang="en-US" smtClean="0"/>
+              <a:rPr lang="en-US"/>
               <a:t>Fourth level</a:t>
             </a:r>
           </a:p>
           <a:p>
             <a:pPr lvl="4"/>
             <a:r>
-              <a:rPr lang="en-US" smtClean="0"/>
+              <a:rPr lang="en-US"/>
               <a:t>Fifth level</a:t>
             </a:r>
-            <a:endParaRPr lang="en-US"/>
           </a:p>
         </p:txBody>
       </p:sp>
@@ -817,7 +825,7 @@
           <a:p>
             <a:fld id="{5BCAD085-E8A6-8845-BD4E-CB4CCA059FC4}" type="datetimeFigureOut">
               <a:rPr lang="en-US" smtClean="0"/>
-              <a:t>1/27/13</a:t>
+              <a:t>7/24/26</a:t>
             </a:fld>
             <a:endParaRPr lang="en-US"/>
           </a:p>
@@ -907,8 +915,8 @@
         </p:nvSpPr>
         <p:spPr>
           <a:xfrm>
-            <a:off x="722313" y="4406900"/>
-            <a:ext cx="7772400" cy="1362075"/>
+            <a:off x="963084" y="4406901"/>
+            <a:ext cx="10363200" cy="1362075"/>
           </a:xfrm>
         </p:spPr>
         <p:txBody>
@@ -920,10 +928,9 @@
           </a:lstStyle>
           <a:p>
             <a:r>
-              <a:rPr lang="en-US" smtClean="0"/>
+              <a:rPr lang="en-US"/>
               <a:t>Click to edit Master title style</a:t>
             </a:r>
-            <a:endParaRPr lang="en-US"/>
           </a:p>
         </p:txBody>
       </p:sp>
@@ -939,8 +946,8 @@
         </p:nvSpPr>
         <p:spPr>
           <a:xfrm>
-            <a:off x="722313" y="2906713"/>
-            <a:ext cx="7772400" cy="1500187"/>
+            <a:off x="963084" y="2906713"/>
+            <a:ext cx="10363200" cy="1500187"/>
           </a:xfrm>
         </p:spPr>
         <p:txBody>
@@ -1040,7 +1047,7 @@
           <a:p>
             <a:pPr lvl="0"/>
             <a:r>
-              <a:rPr lang="en-US" smtClean="0"/>
+              <a:rPr lang="en-US"/>
               <a:t>Click to edit Master text styles</a:t>
             </a:r>
           </a:p>
@@ -1063,7 +1070,7 @@
           <a:p>
             <a:fld id="{5BCAD085-E8A6-8845-BD4E-CB4CCA059FC4}" type="datetimeFigureOut">
               <a:rPr lang="en-US" smtClean="0"/>
-              <a:t>1/27/13</a:t>
+              <a:t>7/24/26</a:t>
             </a:fld>
             <a:endParaRPr lang="en-US"/>
           </a:p>
@@ -1157,10 +1164,9 @@
           <a:lstStyle/>
           <a:p>
             <a:r>
-              <a:rPr lang="en-US" smtClean="0"/>
+              <a:rPr lang="en-US"/>
               <a:t>Click to edit Master title style</a:t>
             </a:r>
-            <a:endParaRPr lang="en-US"/>
           </a:p>
         </p:txBody>
       </p:sp>
@@ -1176,8 +1182,8 @@
         </p:nvSpPr>
         <p:spPr>
           <a:xfrm>
-            <a:off x="457200" y="1600200"/>
-            <a:ext cx="4038600" cy="4525963"/>
+            <a:off x="609600" y="1600201"/>
+            <a:ext cx="5384800" cy="4525963"/>
           </a:xfrm>
         </p:spPr>
         <p:txBody>
@@ -1214,38 +1220,37 @@
           <a:p>
             <a:pPr lvl="0"/>
             <a:r>
-              <a:rPr lang="en-US" smtClean="0"/>
+              <a:rPr lang="en-US"/>
               <a:t>Click to edit Master text styles</a:t>
             </a:r>
           </a:p>
           <a:p>
             <a:pPr lvl="1"/>
             <a:r>
-              <a:rPr lang="en-US" smtClean="0"/>
+              <a:rPr lang="en-US"/>
               <a:t>Second level</a:t>
             </a:r>
           </a:p>
           <a:p>
             <a:pPr lvl="2"/>
             <a:r>
-              <a:rPr lang="en-US" smtClean="0"/>
+              <a:rPr lang="en-US"/>
               <a:t>Third level</a:t>
             </a:r>
           </a:p>
           <a:p>
             <a:pPr lvl="3"/>
             <a:r>
-              <a:rPr lang="en-US" smtClean="0"/>
+              <a:rPr lang="en-US"/>
               <a:t>Fourth level</a:t>
             </a:r>
           </a:p>
           <a:p>
             <a:pPr lvl="4"/>
             <a:r>
-              <a:rPr lang="en-US" smtClean="0"/>
+              <a:rPr lang="en-US"/>
               <a:t>Fifth level</a:t>
             </a:r>
-            <a:endParaRPr lang="en-US"/>
           </a:p>
         </p:txBody>
       </p:sp>
@@ -1261,8 +1266,8 @@
         </p:nvSpPr>
         <p:spPr>
           <a:xfrm>
-            <a:off x="4648200" y="1600200"/>
-            <a:ext cx="4038600" cy="4525963"/>
+            <a:off x="6197600" y="1600201"/>
+            <a:ext cx="5384800" cy="4525963"/>
           </a:xfrm>
         </p:spPr>
         <p:txBody>
@@ -1299,38 +1304,37 @@
           <a:p>
             <a:pPr lvl="0"/>
             <a:r>
-              <a:rPr lang="en-US" smtClean="0"/>
+              <a:rPr lang="en-US"/>
               <a:t>Click to edit Master text styles</a:t>
             </a:r>
           </a:p>
           <a:p>
             <a:pPr lvl="1"/>
             <a:r>
-              <a:rPr lang="en-US" smtClean="0"/>
+              <a:rPr lang="en-US"/>
               <a:t>Second level</a:t>
             </a:r>
           </a:p>
           <a:p>
             <a:pPr lvl="2"/>
             <a:r>
-              <a:rPr lang="en-US" smtClean="0"/>
+              <a:rPr lang="en-US"/>
               <a:t>Third level</a:t>
             </a:r>
           </a:p>
           <a:p>
             <a:pPr lvl="3"/>
             <a:r>
-              <a:rPr lang="en-US" smtClean="0"/>
+              <a:rPr lang="en-US"/>
               <a:t>Fourth level</a:t>
             </a:r>
           </a:p>
           <a:p>
             <a:pPr lvl="4"/>
             <a:r>
-              <a:rPr lang="en-US" smtClean="0"/>
+              <a:rPr lang="en-US"/>
               <a:t>Fifth level</a:t>
             </a:r>
-            <a:endParaRPr lang="en-US"/>
           </a:p>
         </p:txBody>
       </p:sp>
@@ -1351,7 +1355,7 @@
           <a:p>
             <a:fld id="{5BCAD085-E8A6-8845-BD4E-CB4CCA059FC4}" type="datetimeFigureOut">
               <a:rPr lang="en-US" smtClean="0"/>
-              <a:t>1/27/13</a:t>
+              <a:t>7/24/26</a:t>
             </a:fld>
             <a:endParaRPr lang="en-US"/>
           </a:p>
@@ -1449,10 +1453,9 @@
           </a:lstStyle>
           <a:p>
             <a:r>
-              <a:rPr lang="en-US" smtClean="0"/>
+              <a:rPr lang="en-US"/>
               <a:t>Click to edit Master title style</a:t>
             </a:r>
-            <a:endParaRPr lang="en-US"/>
           </a:p>
         </p:txBody>
       </p:sp>
@@ -1468,8 +1471,8 @@
         </p:nvSpPr>
         <p:spPr>
           <a:xfrm>
-            <a:off x="457200" y="1535113"/>
-            <a:ext cx="4040188" cy="639762"/>
+            <a:off x="609600" y="1535113"/>
+            <a:ext cx="5386917" cy="639762"/>
           </a:xfrm>
         </p:spPr>
         <p:txBody>
@@ -1515,7 +1518,7 @@
           <a:p>
             <a:pPr lvl="0"/>
             <a:r>
-              <a:rPr lang="en-US" smtClean="0"/>
+              <a:rPr lang="en-US"/>
               <a:t>Click to edit Master text styles</a:t>
             </a:r>
           </a:p>
@@ -1533,8 +1536,8 @@
         </p:nvSpPr>
         <p:spPr>
           <a:xfrm>
-            <a:off x="457200" y="2174875"/>
-            <a:ext cx="4040188" cy="3951288"/>
+            <a:off x="609600" y="2174875"/>
+            <a:ext cx="5386917" cy="3951288"/>
           </a:xfrm>
         </p:spPr>
         <p:txBody>
@@ -1571,38 +1574,37 @@
           <a:p>
             <a:pPr lvl="0"/>
             <a:r>
-              <a:rPr lang="en-US" smtClean="0"/>
+              <a:rPr lang="en-US"/>
               <a:t>Click to edit Master text styles</a:t>
             </a:r>
           </a:p>
           <a:p>
             <a:pPr lvl="1"/>
             <a:r>
-              <a:rPr lang="en-US" smtClean="0"/>
+              <a:rPr lang="en-US"/>
               <a:t>Second level</a:t>
             </a:r>
           </a:p>
           <a:p>
             <a:pPr lvl="2"/>
             <a:r>
-              <a:rPr lang="en-US" smtClean="0"/>
+              <a:rPr lang="en-US"/>
               <a:t>Third level</a:t>
             </a:r>
           </a:p>
           <a:p>
             <a:pPr lvl="3"/>
             <a:r>
-              <a:rPr lang="en-US" smtClean="0"/>
+              <a:rPr lang="en-US"/>
               <a:t>Fourth level</a:t>
             </a:r>
           </a:p>
           <a:p>
             <a:pPr lvl="4"/>
             <a:r>
-              <a:rPr lang="en-US" smtClean="0"/>
+              <a:rPr lang="en-US"/>
               <a:t>Fifth level</a:t>
             </a:r>
-            <a:endParaRPr lang="en-US"/>
           </a:p>
         </p:txBody>
       </p:sp>
@@ -1618,8 +1620,8 @@
         </p:nvSpPr>
         <p:spPr>
           <a:xfrm>
-            <a:off x="4645025" y="1535113"/>
-            <a:ext cx="4041775" cy="639762"/>
+            <a:off x="6193368" y="1535113"/>
+            <a:ext cx="5389033" cy="639762"/>
           </a:xfrm>
         </p:spPr>
         <p:txBody>
@@ -1665,7 +1667,7 @@
           <a:p>
             <a:pPr lvl="0"/>
             <a:r>
-              <a:rPr lang="en-US" smtClean="0"/>
+              <a:rPr lang="en-US"/>
               <a:t>Click to edit Master text styles</a:t>
             </a:r>
           </a:p>
@@ -1683,8 +1685,8 @@
         </p:nvSpPr>
         <p:spPr>
           <a:xfrm>
-            <a:off x="4645025" y="2174875"/>
-            <a:ext cx="4041775" cy="3951288"/>
+            <a:off x="6193368" y="2174875"/>
+            <a:ext cx="5389033" cy="3951288"/>
           </a:xfrm>
         </p:spPr>
         <p:txBody>
@@ -1721,38 +1723,37 @@
           <a:p>
             <a:pPr lvl="0"/>
             <a:r>
-              <a:rPr lang="en-US" smtClean="0"/>
+              <a:rPr lang="en-US"/>
               <a:t>Click to edit Master text styles</a:t>
             </a:r>
           </a:p>
           <a:p>
             <a:pPr lvl="1"/>
             <a:r>
-              <a:rPr lang="en-US" smtClean="0"/>
+              <a:rPr lang="en-US"/>
               <a:t>Second level</a:t>
             </a:r>
           </a:p>
           <a:p>
             <a:pPr lvl="2"/>
             <a:r>
-              <a:rPr lang="en-US" smtClean="0"/>
+              <a:rPr lang="en-US"/>
               <a:t>Third level</a:t>
             </a:r>
           </a:p>
           <a:p>
             <a:pPr lvl="3"/>
             <a:r>
-              <a:rPr lang="en-US" smtClean="0"/>
+              <a:rPr lang="en-US"/>
               <a:t>Fourth level</a:t>
             </a:r>
           </a:p>
           <a:p>
             <a:pPr lvl="4"/>
             <a:r>
-              <a:rPr lang="en-US" smtClean="0"/>
+              <a:rPr lang="en-US"/>
               <a:t>Fifth level</a:t>
             </a:r>
-            <a:endParaRPr lang="en-US"/>
           </a:p>
         </p:txBody>
       </p:sp>
@@ -1773,7 +1774,7 @@
           <a:p>
             <a:fld id="{5BCAD085-E8A6-8845-BD4E-CB4CCA059FC4}" type="datetimeFigureOut">
               <a:rPr lang="en-US" smtClean="0"/>
-              <a:t>1/27/13</a:t>
+              <a:t>7/24/26</a:t>
             </a:fld>
             <a:endParaRPr lang="en-US"/>
           </a:p>
@@ -1867,10 +1868,9 @@
           <a:lstStyle/>
           <a:p>
             <a:r>
-              <a:rPr lang="en-US" smtClean="0"/>
+              <a:rPr lang="en-US"/>
               <a:t>Click to edit Master title style</a:t>
             </a:r>
-            <a:endParaRPr lang="en-US"/>
           </a:p>
         </p:txBody>
       </p:sp>
@@ -1891,7 +1891,7 @@
           <a:p>
             <a:fld id="{5BCAD085-E8A6-8845-BD4E-CB4CCA059FC4}" type="datetimeFigureOut">
               <a:rPr lang="en-US" smtClean="0"/>
-              <a:t>1/27/13</a:t>
+              <a:t>7/24/26</a:t>
             </a:fld>
             <a:endParaRPr lang="en-US"/>
           </a:p>
@@ -1986,7 +1986,7 @@
           <a:p>
             <a:fld id="{5BCAD085-E8A6-8845-BD4E-CB4CCA059FC4}" type="datetimeFigureOut">
               <a:rPr lang="en-US" smtClean="0"/>
-              <a:t>1/27/13</a:t>
+              <a:t>7/24/26</a:t>
             </a:fld>
             <a:endParaRPr lang="en-US"/>
           </a:p>
@@ -2076,8 +2076,8 @@
         </p:nvSpPr>
         <p:spPr>
           <a:xfrm>
-            <a:off x="457200" y="273050"/>
-            <a:ext cx="3008313" cy="1162050"/>
+            <a:off x="609601" y="273050"/>
+            <a:ext cx="4011084" cy="1162050"/>
           </a:xfrm>
         </p:spPr>
         <p:txBody>
@@ -2089,10 +2089,9 @@
           </a:lstStyle>
           <a:p>
             <a:r>
-              <a:rPr lang="en-US" smtClean="0"/>
+              <a:rPr lang="en-US"/>
               <a:t>Click to edit Master title style</a:t>
             </a:r>
-            <a:endParaRPr lang="en-US"/>
           </a:p>
         </p:txBody>
       </p:sp>
@@ -2108,8 +2107,8 @@
         </p:nvSpPr>
         <p:spPr>
           <a:xfrm>
-            <a:off x="3575050" y="273050"/>
-            <a:ext cx="5111750" cy="5853113"/>
+            <a:off x="4766733" y="273051"/>
+            <a:ext cx="6815667" cy="5853113"/>
           </a:xfrm>
         </p:spPr>
         <p:txBody>
@@ -2146,38 +2145,37 @@
           <a:p>
             <a:pPr lvl="0"/>
             <a:r>
-              <a:rPr lang="en-US" smtClean="0"/>
+              <a:rPr lang="en-US"/>
               <a:t>Click to edit Master text styles</a:t>
             </a:r>
           </a:p>
           <a:p>
             <a:pPr lvl="1"/>
             <a:r>
-              <a:rPr lang="en-US" smtClean="0"/>
+              <a:rPr lang="en-US"/>
               <a:t>Second level</a:t>
             </a:r>
           </a:p>
           <a:p>
             <a:pPr lvl="2"/>
             <a:r>
-              <a:rPr lang="en-US" smtClean="0"/>
+              <a:rPr lang="en-US"/>
               <a:t>Third level</a:t>
             </a:r>
           </a:p>
           <a:p>
             <a:pPr lvl="3"/>
             <a:r>
-              <a:rPr lang="en-US" smtClean="0"/>
+              <a:rPr lang="en-US"/>
               <a:t>Fourth level</a:t>
             </a:r>
           </a:p>
           <a:p>
             <a:pPr lvl="4"/>
             <a:r>
-              <a:rPr lang="en-US" smtClean="0"/>
+              <a:rPr lang="en-US"/>
               <a:t>Fifth level</a:t>
             </a:r>
-            <a:endParaRPr lang="en-US"/>
           </a:p>
         </p:txBody>
       </p:sp>
@@ -2193,8 +2191,8 @@
         </p:nvSpPr>
         <p:spPr>
           <a:xfrm>
-            <a:off x="457200" y="1435100"/>
-            <a:ext cx="3008313" cy="4691063"/>
+            <a:off x="609601" y="1435101"/>
+            <a:ext cx="4011084" cy="4691063"/>
           </a:xfrm>
         </p:spPr>
         <p:txBody>
@@ -2240,7 +2238,7 @@
           <a:p>
             <a:pPr lvl="0"/>
             <a:r>
-              <a:rPr lang="en-US" smtClean="0"/>
+              <a:rPr lang="en-US"/>
               <a:t>Click to edit Master text styles</a:t>
             </a:r>
           </a:p>
@@ -2263,7 +2261,7 @@
           <a:p>
             <a:fld id="{5BCAD085-E8A6-8845-BD4E-CB4CCA059FC4}" type="datetimeFigureOut">
               <a:rPr lang="en-US" smtClean="0"/>
-              <a:t>1/27/13</a:t>
+              <a:t>7/24/26</a:t>
             </a:fld>
             <a:endParaRPr lang="en-US"/>
           </a:p>
@@ -2353,8 +2351,8 @@
         </p:nvSpPr>
         <p:spPr>
           <a:xfrm>
-            <a:off x="1792288" y="4800600"/>
-            <a:ext cx="5486400" cy="566738"/>
+            <a:off x="2389717" y="4800600"/>
+            <a:ext cx="7315200" cy="566738"/>
           </a:xfrm>
         </p:spPr>
         <p:txBody>
@@ -2366,10 +2364,9 @@
           </a:lstStyle>
           <a:p>
             <a:r>
-              <a:rPr lang="en-US" smtClean="0"/>
+              <a:rPr lang="en-US"/>
               <a:t>Click to edit Master title style</a:t>
             </a:r>
-            <a:endParaRPr lang="en-US"/>
           </a:p>
         </p:txBody>
       </p:sp>
@@ -2385,8 +2382,8 @@
         </p:nvSpPr>
         <p:spPr>
           <a:xfrm>
-            <a:off x="1792288" y="612775"/>
-            <a:ext cx="5486400" cy="4114800"/>
+            <a:off x="2389717" y="612775"/>
+            <a:ext cx="7315200" cy="4114800"/>
           </a:xfrm>
         </p:spPr>
         <p:txBody>
@@ -2446,8 +2443,8 @@
         </p:nvSpPr>
         <p:spPr>
           <a:xfrm>
-            <a:off x="1792288" y="5367338"/>
-            <a:ext cx="5486400" cy="804862"/>
+            <a:off x="2389717" y="5367338"/>
+            <a:ext cx="7315200" cy="804862"/>
           </a:xfrm>
         </p:spPr>
         <p:txBody>
@@ -2493,7 +2490,7 @@
           <a:p>
             <a:pPr lvl="0"/>
             <a:r>
-              <a:rPr lang="en-US" smtClean="0"/>
+              <a:rPr lang="en-US"/>
               <a:t>Click to edit Master text styles</a:t>
             </a:r>
           </a:p>
@@ -2516,7 +2513,7 @@
           <a:p>
             <a:fld id="{5BCAD085-E8A6-8845-BD4E-CB4CCA059FC4}" type="datetimeFigureOut">
               <a:rPr lang="en-US" smtClean="0"/>
-              <a:t>1/27/13</a:t>
+              <a:t>7/24/26</a:t>
             </a:fld>
             <a:endParaRPr lang="en-US"/>
           </a:p>
@@ -2611,8 +2608,8 @@
         </p:nvSpPr>
         <p:spPr>
           <a:xfrm>
-            <a:off x="457200" y="274638"/>
-            <a:ext cx="8229600" cy="1143000"/>
+            <a:off x="609600" y="274638"/>
+            <a:ext cx="10972800" cy="1143000"/>
           </a:xfrm>
           <a:prstGeom prst="rect">
             <a:avLst/>
@@ -2625,10 +2622,9 @@
           <a:lstStyle/>
           <a:p>
             <a:r>
-              <a:rPr lang="en-US" smtClean="0"/>
+              <a:rPr lang="en-US"/>
               <a:t>Click to edit Master title style</a:t>
             </a:r>
-            <a:endParaRPr lang="en-US"/>
           </a:p>
         </p:txBody>
       </p:sp>
@@ -2644,8 +2640,8 @@
         </p:nvSpPr>
         <p:spPr>
           <a:xfrm>
-            <a:off x="457200" y="1600200"/>
-            <a:ext cx="8229600" cy="4525963"/>
+            <a:off x="609600" y="1600201"/>
+            <a:ext cx="10972800" cy="4525963"/>
           </a:xfrm>
           <a:prstGeom prst="rect">
             <a:avLst/>
@@ -2659,38 +2655,37 @@
           <a:p>
             <a:pPr lvl="0"/>
             <a:r>
-              <a:rPr lang="en-US" smtClean="0"/>
+              <a:rPr lang="en-US"/>
               <a:t>Click to edit Master text styles</a:t>
             </a:r>
           </a:p>
           <a:p>
             <a:pPr lvl="1"/>
             <a:r>
-              <a:rPr lang="en-US" smtClean="0"/>
+              <a:rPr lang="en-US"/>
               <a:t>Second level</a:t>
             </a:r>
           </a:p>
           <a:p>
             <a:pPr lvl="2"/>
             <a:r>
-              <a:rPr lang="en-US" smtClean="0"/>
+              <a:rPr lang="en-US"/>
               <a:t>Third level</a:t>
             </a:r>
           </a:p>
           <a:p>
             <a:pPr lvl="3"/>
             <a:r>
-              <a:rPr lang="en-US" smtClean="0"/>
+              <a:rPr lang="en-US"/>
               <a:t>Fourth level</a:t>
             </a:r>
           </a:p>
           <a:p>
             <a:pPr lvl="4"/>
             <a:r>
-              <a:rPr lang="en-US" smtClean="0"/>
+              <a:rPr lang="en-US"/>
               <a:t>Fifth level</a:t>
             </a:r>
-            <a:endParaRPr lang="en-US"/>
           </a:p>
         </p:txBody>
       </p:sp>
@@ -2706,8 +2701,8 @@
         </p:nvSpPr>
         <p:spPr>
           <a:xfrm>
-            <a:off x="457200" y="6356350"/>
-            <a:ext cx="2133600" cy="365125"/>
+            <a:off x="609600" y="6356351"/>
+            <a:ext cx="2844800" cy="365125"/>
           </a:xfrm>
           <a:prstGeom prst="rect">
             <a:avLst/>
@@ -2729,7 +2724,7 @@
           <a:p>
             <a:fld id="{5BCAD085-E8A6-8845-BD4E-CB4CCA059FC4}" type="datetimeFigureOut">
               <a:rPr lang="en-US" smtClean="0"/>
-              <a:t>1/27/13</a:t>
+              <a:t>7/24/26</a:t>
             </a:fld>
             <a:endParaRPr lang="en-US"/>
           </a:p>
@@ -2747,8 +2742,8 @@
         </p:nvSpPr>
         <p:spPr>
           <a:xfrm>
-            <a:off x="3124200" y="6356350"/>
-            <a:ext cx="2895600" cy="365125"/>
+            <a:off x="4165600" y="6356351"/>
+            <a:ext cx="3860800" cy="365125"/>
           </a:xfrm>
           <a:prstGeom prst="rect">
             <a:avLst/>
@@ -2784,8 +2779,8 @@
         </p:nvSpPr>
         <p:spPr>
           <a:xfrm>
-            <a:off x="6553200" y="6356350"/>
-            <a:ext cx="2133600" cy="365125"/>
+            <a:off x="8737600" y="6356351"/>
+            <a:ext cx="2844800" cy="365125"/>
           </a:xfrm>
           <a:prstGeom prst="rect">
             <a:avLst/>
@@ -3088,7 +3083,7 @@
 </file>
 
 <file path=ppt/slides/slide1.xml><?xml version="1.0" encoding="utf-8"?>
-<p:sld xmlns:a="http://schemas.openxmlformats.org/drawingml/2006/main" xmlns:p="http://schemas.openxmlformats.org/presentationml/2006/main" xmlns:r="http://schemas.openxmlformats.org/officeDocument/2006/relationships">
+<p:sld xmlns:a="http://schemas.openxmlformats.org/drawingml/2006/main" xmlns:r="http://schemas.openxmlformats.org/officeDocument/2006/relationships" xmlns:p="http://schemas.openxmlformats.org/presentationml/2006/main">
   <p:cSld>
     <p:spTree>
       <p:nvGrpSpPr>
@@ -3096,7 +3091,14 @@
         <p:cNvGrpSpPr/>
         <p:nvPr/>
       </p:nvGrpSpPr>
-      <p:grpSpPr/>
+      <p:grpSpPr>
+        <a:xfrm>
+          <a:off x="0" y="0"/>
+          <a:ext cx="0" cy="0"/>
+          <a:chOff x="0" y="0"/>
+          <a:chExt cx="0" cy="0"/>
+        </a:xfrm>
+      </p:grpSpPr>
       <p:sp>
         <p:nvSpPr>
           <p:cNvPr id="2" name="TextBox 1"/>
@@ -3105,8 +3107,8 @@
         </p:nvSpPr>
         <p:spPr>
           <a:xfrm>
-            <a:off x="457200" y="2286000"/>
-            <a:ext cx="8229600" cy="914400"/>
+            <a:off x="2777303" y="2286001"/>
+            <a:ext cx="6637394" cy="769441"/>
           </a:xfrm>
           <a:prstGeom prst="rect">
             <a:avLst/>
@@ -3127,6 +3129,7 @@
               </a:defRPr>
             </a:pPr>
             <a:r>
+              <a:rPr sz="4400"/>
               <a:t>ISO Compliance AI Platform</a:t>
             </a:r>
           </a:p>
@@ -3140,8 +3143,8 @@
         </p:nvSpPr>
         <p:spPr>
           <a:xfrm>
-            <a:off x="457200" y="3200400"/>
-            <a:ext cx="8229600" cy="548640"/>
+            <a:off x="2493957" y="3200400"/>
+            <a:ext cx="7204087" cy="523220"/>
           </a:xfrm>
           <a:prstGeom prst="rect">
             <a:avLst/>
@@ -3162,6 +3165,7 @@
               </a:defRPr>
             </a:pPr>
             <a:r>
+              <a:rPr sz="2800" dirty="0"/>
               <a:t>Enterprise-Grade AI on Red Hat OpenShift AI 3.5</a:t>
             </a:r>
           </a:p>
@@ -3175,8 +3179,8 @@
         </p:nvSpPr>
         <p:spPr>
           <a:xfrm>
-            <a:off x="914400" y="4572000"/>
-            <a:ext cx="7315200" cy="1371600"/>
+            <a:off x="3622631" y="4572001"/>
+            <a:ext cx="4946739" cy="615553"/>
           </a:xfrm>
           <a:prstGeom prst="rect">
             <a:avLst/>
@@ -3197,13 +3201,25 @@
               </a:defRPr>
             </a:pPr>
             <a:r>
+              <a:rPr sz="1600" dirty="0"/>
               <a:t>Model as a Service · GPT-oss-20b · BGE-M3 · Vector RAG</a:t>
             </a:r>
           </a:p>
           <a:p>
-            <a:r>
-              <a:t>TrustyAI Guardrails · Grafana Observability · GitOps</a:t>
-            </a:r>
+            <a:pPr algn="ctr"/>
+            <a:r>
+              <a:rPr dirty="0" err="1"/>
+              <a:t>TrustyAI</a:t>
+            </a:r>
+            <a:r>
+              <a:rPr dirty="0"/>
+              <a:t> Guardrails · Grafana Observability · </a:t>
+            </a:r>
+            <a:r>
+              <a:rPr dirty="0" err="1"/>
+              <a:t>GitOps</a:t>
+            </a:r>
+            <a:endParaRPr dirty="0"/>
           </a:p>
         </p:txBody>
       </p:sp>
@@ -3216,7 +3232,7 @@
 </file>
 
 <file path=ppt/slides/slide10.xml><?xml version="1.0" encoding="utf-8"?>
-<p:sld xmlns:a="http://schemas.openxmlformats.org/drawingml/2006/main" xmlns:p="http://schemas.openxmlformats.org/presentationml/2006/main" xmlns:r="http://schemas.openxmlformats.org/officeDocument/2006/relationships">
+<p:sld xmlns:a="http://schemas.openxmlformats.org/drawingml/2006/main" xmlns:r="http://schemas.openxmlformats.org/officeDocument/2006/relationships" xmlns:p="http://schemas.openxmlformats.org/presentationml/2006/main">
   <p:cSld>
     <p:spTree>
       <p:nvGrpSpPr>
@@ -3224,7 +3240,14 @@
         <p:cNvGrpSpPr/>
         <p:nvPr/>
       </p:nvGrpSpPr>
-      <p:grpSpPr/>
+      <p:grpSpPr>
+        <a:xfrm>
+          <a:off x="0" y="0"/>
+          <a:ext cx="0" cy="0"/>
+          <a:chOff x="0" y="0"/>
+          <a:chExt cx="0" cy="0"/>
+        </a:xfrm>
+      </p:grpSpPr>
       <p:sp>
         <p:nvSpPr>
           <p:cNvPr id="2" name="TextBox 1"/>
@@ -3233,8 +3256,8 @@
         </p:nvSpPr>
         <p:spPr>
           <a:xfrm>
-            <a:off x="457200" y="274320"/>
-            <a:ext cx="8229600" cy="640080"/>
+            <a:off x="1981201" y="274321"/>
+            <a:ext cx="4285597" cy="584775"/>
           </a:xfrm>
           <a:prstGeom prst="rect">
             <a:avLst/>
@@ -3255,6 +3278,7 @@
               </a:defRPr>
             </a:pPr>
             <a:r>
+              <a:rPr sz="3200"/>
               <a:t>Results &amp; Achievements</a:t>
             </a:r>
           </a:p>
@@ -3268,8 +3292,8 @@
         </p:nvSpPr>
         <p:spPr>
           <a:xfrm>
-            <a:off x="457200" y="1371600"/>
-            <a:ext cx="8229600" cy="4572000"/>
+            <a:off x="1981200" y="1371601"/>
+            <a:ext cx="6818662" cy="3421449"/>
           </a:xfrm>
           <a:prstGeom prst="rect">
             <a:avLst/>
@@ -3293,6 +3317,7 @@
               </a:defRPr>
             </a:pPr>
             <a:r>
+              <a:rPr sz="2000"/>
               <a:t>Technical Achievements:</a:t>
             </a:r>
           </a:p>
@@ -3304,6 +3329,7 @@
               <a:defRPr sz="1500"/>
             </a:pPr>
             <a:r>
+              <a:rPr sz="1500"/>
               <a:t>✓ 100% clause extraction (94/94 vs 21/94 with regex)</a:t>
             </a:r>
           </a:p>
@@ -3315,6 +3341,7 @@
               <a:defRPr sz="1500"/>
             </a:pPr>
             <a:r>
+              <a:rPr sz="1500"/>
               <a:t>✓ Semantic search &lt;100ms query time</a:t>
             </a:r>
           </a:p>
@@ -3326,6 +3353,7 @@
               <a:defRPr sz="1500"/>
             </a:pPr>
             <a:r>
+              <a:rPr sz="1500"/>
               <a:t>✓ Multilingual RAG (EN/HE) with 1024-dim embeddings</a:t>
             </a:r>
           </a:p>
@@ -3337,6 +3365,7 @@
               <a:defRPr sz="1500"/>
             </a:pPr>
             <a:r>
+              <a:rPr sz="1500"/>
               <a:t>✓ Full observability: Grafana + Prometheus + TrustyAI</a:t>
             </a:r>
           </a:p>
@@ -3348,6 +3377,7 @@
               <a:defRPr sz="1500"/>
             </a:pPr>
             <a:r>
+              <a:rPr sz="1500"/>
               <a:t>✓ Enterprise security: OAuth + MaaS + Guardrails</a:t>
             </a:r>
           </a:p>
@@ -3359,6 +3389,7 @@
               <a:defRPr sz="1500"/>
             </a:pPr>
             <a:r>
+              <a:rPr sz="1500"/>
               <a:t>✓ 100% GitOps automation (4 layers, auto-sync)</a:t>
             </a:r>
           </a:p>
@@ -3368,6 +3399,7 @@
                 <a:spcPts val="1200"/>
               </a:spcAft>
             </a:pPr>
+            <a:endParaRPr/>
           </a:p>
           <a:p>
             <a:pPr>
@@ -3381,6 +3413,7 @@
               </a:defRPr>
             </a:pPr>
             <a:r>
+              <a:rPr sz="2000"/>
               <a:t>Business Impact:</a:t>
             </a:r>
           </a:p>
@@ -3389,6 +3422,7 @@
               <a:defRPr sz="1500"/>
             </a:pPr>
             <a:r>
+              <a:rPr sz="1500"/>
               <a:t>70% faster clause mapping · Real-time semantic search · Enterprise-grade AI platform</a:t>
             </a:r>
           </a:p>
@@ -3403,7 +3437,7 @@
 </file>
 
 <file path=ppt/slides/slide2.xml><?xml version="1.0" encoding="utf-8"?>
-<p:sld xmlns:a="http://schemas.openxmlformats.org/drawingml/2006/main" xmlns:p="http://schemas.openxmlformats.org/presentationml/2006/main" xmlns:r="http://schemas.openxmlformats.org/officeDocument/2006/relationships">
+<p:sld xmlns:a="http://schemas.openxmlformats.org/drawingml/2006/main" xmlns:r="http://schemas.openxmlformats.org/officeDocument/2006/relationships" xmlns:p="http://schemas.openxmlformats.org/presentationml/2006/main">
   <p:cSld>
     <p:spTree>
       <p:nvGrpSpPr>
@@ -3411,7 +3445,14 @@
         <p:cNvGrpSpPr/>
         <p:nvPr/>
       </p:nvGrpSpPr>
-      <p:grpSpPr/>
+      <p:grpSpPr>
+        <a:xfrm>
+          <a:off x="0" y="0"/>
+          <a:ext cx="0" cy="0"/>
+          <a:chOff x="0" y="0"/>
+          <a:chExt cx="0" cy="0"/>
+        </a:xfrm>
+      </p:grpSpPr>
       <p:sp>
         <p:nvSpPr>
           <p:cNvPr id="2" name="TextBox 1"/>
@@ -3420,8 +3461,8 @@
         </p:nvSpPr>
         <p:spPr>
           <a:xfrm>
-            <a:off x="457200" y="274320"/>
-            <a:ext cx="8229600" cy="640080"/>
+            <a:off x="1981200" y="274321"/>
+            <a:ext cx="5081648" cy="584775"/>
           </a:xfrm>
           <a:prstGeom prst="rect">
             <a:avLst/>
@@ -3442,6 +3483,7 @@
               </a:defRPr>
             </a:pPr>
             <a:r>
+              <a:rPr sz="3200"/>
               <a:t>Business Problem &amp; Solution</a:t>
             </a:r>
           </a:p>
@@ -3455,8 +3497,8 @@
         </p:nvSpPr>
         <p:spPr>
           <a:xfrm>
-            <a:off x="457200" y="1371600"/>
-            <a:ext cx="8229600" cy="4572000"/>
+            <a:off x="1981200" y="1371600"/>
+            <a:ext cx="8229600" cy="3883114"/>
           </a:xfrm>
           <a:prstGeom prst="rect">
             <a:avLst/>
@@ -3480,6 +3522,7 @@
               </a:defRPr>
             </a:pPr>
             <a:r>
+              <a:rPr sz="2400" dirty="0"/>
               <a:t>Challenge:</a:t>
             </a:r>
           </a:p>
@@ -3491,6 +3534,7 @@
               <a:defRPr sz="1800"/>
             </a:pPr>
             <a:r>
+              <a:rPr dirty="0"/>
               <a:t>ISO compliance audits require mapping findings to 94+ clauses across English/Hebrew languages</a:t>
             </a:r>
           </a:p>
@@ -3506,6 +3550,7 @@
               </a:defRPr>
             </a:pPr>
             <a:r>
+              <a:rPr sz="2400" dirty="0"/>
               <a:t>Solution:</a:t>
             </a:r>
           </a:p>
@@ -3517,6 +3562,7 @@
               <a:defRPr sz="1600"/>
             </a:pPr>
             <a:r>
+              <a:rPr sz="1600" dirty="0"/>
               <a:t>✓ LLM-based clause extraction (94 clauses vs 21 with regex)</a:t>
             </a:r>
           </a:p>
@@ -3528,6 +3574,7 @@
               <a:defRPr sz="1600"/>
             </a:pPr>
             <a:r>
+              <a:rPr sz="1600" dirty="0"/>
               <a:t>✓ Semantic search with BGE-M3 multilingual embeddings</a:t>
             </a:r>
           </a:p>
@@ -3539,6 +3586,7 @@
               <a:defRPr sz="1600"/>
             </a:pPr>
             <a:r>
+              <a:rPr sz="1600" dirty="0"/>
               <a:t>✓ Bilingual EN/HE support with RTL layout</a:t>
             </a:r>
           </a:p>
@@ -3550,6 +3598,7 @@
               <a:defRPr sz="1600"/>
             </a:pPr>
             <a:r>
+              <a:rPr sz="1600" dirty="0"/>
               <a:t>✓ AI-assisted compliance report generation</a:t>
             </a:r>
           </a:p>
@@ -3565,6 +3614,7 @@
               </a:defRPr>
             </a:pPr>
             <a:r>
+              <a:rPr sz="2400" dirty="0"/>
               <a:t>Business Impact:</a:t>
             </a:r>
           </a:p>
@@ -3573,6 +3623,7 @@
               <a:defRPr sz="1600"/>
             </a:pPr>
             <a:r>
+              <a:rPr sz="1600" dirty="0"/>
               <a:t>70% faster clause mapping · 100% extraction accuracy · Real-time semantic search</a:t>
             </a:r>
           </a:p>
@@ -3587,7 +3638,7 @@
 </file>
 
 <file path=ppt/slides/slide3.xml><?xml version="1.0" encoding="utf-8"?>
-<p:sld xmlns:a="http://schemas.openxmlformats.org/drawingml/2006/main" xmlns:p="http://schemas.openxmlformats.org/presentationml/2006/main" xmlns:r="http://schemas.openxmlformats.org/officeDocument/2006/relationships">
+<p:sld xmlns:a="http://schemas.openxmlformats.org/drawingml/2006/main" xmlns:r="http://schemas.openxmlformats.org/officeDocument/2006/relationships" xmlns:p="http://schemas.openxmlformats.org/presentationml/2006/main">
   <p:cSld>
     <p:spTree>
       <p:nvGrpSpPr>
@@ -3595,7 +3646,14 @@
         <p:cNvGrpSpPr/>
         <p:nvPr/>
       </p:nvGrpSpPr>
-      <p:grpSpPr/>
+      <p:grpSpPr>
+        <a:xfrm>
+          <a:off x="0" y="0"/>
+          <a:ext cx="0" cy="0"/>
+          <a:chOff x="0" y="0"/>
+          <a:chExt cx="0" cy="0"/>
+        </a:xfrm>
+      </p:grpSpPr>
       <p:sp>
         <p:nvSpPr>
           <p:cNvPr id="2" name="TextBox 1"/>
@@ -3604,8 +3662,8 @@
         </p:nvSpPr>
         <p:spPr>
           <a:xfrm>
-            <a:off x="457200" y="274320"/>
-            <a:ext cx="8229600" cy="640080"/>
+            <a:off x="1981200" y="274321"/>
+            <a:ext cx="4325992" cy="584775"/>
           </a:xfrm>
           <a:prstGeom prst="rect">
             <a:avLst/>
@@ -3626,6 +3684,7 @@
               </a:defRPr>
             </a:pPr>
             <a:r>
+              <a:rPr sz="3200"/>
               <a:t>Application Architecture</a:t>
             </a:r>
           </a:p>
@@ -3639,7 +3698,7 @@
         </p:nvSpPr>
         <p:spPr>
           <a:xfrm>
-            <a:off x="457200" y="1371600"/>
+            <a:off x="1981200" y="1371600"/>
             <a:ext cx="8229600" cy="4572000"/>
           </a:xfrm>
           <a:prstGeom prst="rect">
@@ -3662,6 +3721,7 @@
               </a:defRPr>
             </a:pPr>
             <a:r>
+              <a:rPr sz="1200"/>
               <a:t>┌─────────────────────────────────────┐</a:t>
             </a:r>
           </a:p>
@@ -3675,6 +3735,7 @@
               </a:defRPr>
             </a:pPr>
             <a:r>
+              <a:rPr sz="1200"/>
               <a:t>│      ISO Web (React SPA)            │</a:t>
             </a:r>
           </a:p>
@@ -3688,6 +3749,7 @@
               </a:defRPr>
             </a:pPr>
             <a:r>
+              <a:rPr sz="1200"/>
               <a:t>│   Bilingual UI (EN/HE) · RTL/LTR    │</a:t>
             </a:r>
           </a:p>
@@ -3701,6 +3763,7 @@
               </a:defRPr>
             </a:pPr>
             <a:r>
+              <a:rPr sz="1200"/>
               <a:t>└──────────────┬──────────────────────┘</a:t>
             </a:r>
           </a:p>
@@ -3714,6 +3777,7 @@
               </a:defRPr>
             </a:pPr>
             <a:r>
+              <a:rPr sz="1200"/>
               <a:t>               │</a:t>
             </a:r>
           </a:p>
@@ -3727,6 +3791,7 @@
               </a:defRPr>
             </a:pPr>
             <a:r>
+              <a:rPr sz="1200"/>
               <a:t>               ▼</a:t>
             </a:r>
           </a:p>
@@ -3740,6 +3805,7 @@
               </a:defRPr>
             </a:pPr>
             <a:r>
+              <a:rPr sz="1200"/>
               <a:t>┌─────────────────────────────────────┐</a:t>
             </a:r>
           </a:p>
@@ -3753,6 +3819,7 @@
               </a:defRPr>
             </a:pPr>
             <a:r>
+              <a:rPr sz="1200"/>
               <a:t>│   ISO API Orchestrator (FastAPI)    │</a:t>
             </a:r>
           </a:p>
@@ -3766,6 +3833,7 @@
               </a:defRPr>
             </a:pPr>
             <a:r>
+              <a:rPr sz="1200"/>
               <a:t>│ Projects · Findings · RAG · Mapping  │</a:t>
             </a:r>
           </a:p>
@@ -3779,6 +3847,7 @@
               </a:defRPr>
             </a:pPr>
             <a:r>
+              <a:rPr sz="1200"/>
               <a:t>└─┬───────┬───────┬───────────────────┘</a:t>
             </a:r>
           </a:p>
@@ -3792,6 +3861,7 @@
               </a:defRPr>
             </a:pPr>
             <a:r>
+              <a:rPr sz="1200"/>
               <a:t>  │       │       │</a:t>
             </a:r>
           </a:p>
@@ -3805,6 +3875,7 @@
               </a:defRPr>
             </a:pPr>
             <a:r>
+              <a:rPr sz="1200"/>
               <a:t>  ▼       ▼       ▼</a:t>
             </a:r>
           </a:p>
@@ -3818,6 +3889,7 @@
               </a:defRPr>
             </a:pPr>
             <a:r>
+              <a:rPr sz="1200"/>
               <a:t>Parse   DocGen  PostgreSQL+pgvector</a:t>
             </a:r>
           </a:p>
@@ -3831,6 +3903,7 @@
               </a:defRPr>
             </a:pPr>
             <a:r>
+              <a:rPr sz="1200"/>
               <a:t>  │       │       │</a:t>
             </a:r>
           </a:p>
@@ -3844,6 +3917,7 @@
               </a:defRPr>
             </a:pPr>
             <a:r>
+              <a:rPr sz="1200"/>
               <a:t>  └───────┴───────┘</a:t>
             </a:r>
           </a:p>
@@ -3857,6 +3931,7 @@
               </a:defRPr>
             </a:pPr>
             <a:r>
+              <a:rPr sz="1200"/>
               <a:t>          │</a:t>
             </a:r>
           </a:p>
@@ -3870,6 +3945,7 @@
               </a:defRPr>
             </a:pPr>
             <a:r>
+              <a:rPr sz="1200"/>
               <a:t>          ▼</a:t>
             </a:r>
           </a:p>
@@ -3883,6 +3959,7 @@
               </a:defRPr>
             </a:pPr>
             <a:r>
+              <a:rPr sz="1200"/>
               <a:t>┌─────────────────────────────────────┐</a:t>
             </a:r>
           </a:p>
@@ -3896,6 +3973,7 @@
               </a:defRPr>
             </a:pPr>
             <a:r>
+              <a:rPr sz="1200"/>
               <a:t>│  Red Hat OpenShift AI - MaaS        │</a:t>
             </a:r>
           </a:p>
@@ -3909,6 +3987,7 @@
               </a:defRPr>
             </a:pPr>
             <a:r>
+              <a:rPr sz="1200"/>
               <a:t>│  GPT-oss-20b · Qwen3 · BGE-M3       │</a:t>
             </a:r>
           </a:p>
@@ -3922,6 +4001,7 @@
               </a:defRPr>
             </a:pPr>
             <a:r>
+              <a:rPr sz="1200"/>
               <a:t>└─────────────────────────────────────┘</a:t>
             </a:r>
           </a:p>
@@ -3936,7 +4016,7 @@
 </file>
 
 <file path=ppt/slides/slide4.xml><?xml version="1.0" encoding="utf-8"?>
-<p:sld xmlns:a="http://schemas.openxmlformats.org/drawingml/2006/main" xmlns:p="http://schemas.openxmlformats.org/presentationml/2006/main" xmlns:r="http://schemas.openxmlformats.org/officeDocument/2006/relationships">
+<p:sld xmlns:a="http://schemas.openxmlformats.org/drawingml/2006/main" xmlns:r="http://schemas.openxmlformats.org/officeDocument/2006/relationships" xmlns:p="http://schemas.openxmlformats.org/presentationml/2006/main">
   <p:cSld>
     <p:spTree>
       <p:nvGrpSpPr>
@@ -3944,7 +4024,14 @@
         <p:cNvGrpSpPr/>
         <p:nvPr/>
       </p:nvGrpSpPr>
-      <p:grpSpPr/>
+      <p:grpSpPr>
+        <a:xfrm>
+          <a:off x="0" y="0"/>
+          <a:ext cx="0" cy="0"/>
+          <a:chOff x="0" y="0"/>
+          <a:chExt cx="0" cy="0"/>
+        </a:xfrm>
+      </p:grpSpPr>
       <p:sp>
         <p:nvSpPr>
           <p:cNvPr id="2" name="TextBox 1"/>
@@ -3953,8 +4040,8 @@
         </p:nvSpPr>
         <p:spPr>
           <a:xfrm>
-            <a:off x="457200" y="274320"/>
-            <a:ext cx="8229600" cy="640080"/>
+            <a:off x="1981200" y="274321"/>
+            <a:ext cx="3672800" cy="584775"/>
           </a:xfrm>
           <a:prstGeom prst="rect">
             <a:avLst/>
@@ -3975,6 +4062,7 @@
               </a:defRPr>
             </a:pPr>
             <a:r>
+              <a:rPr sz="3200"/>
               <a:t>LLM Model Portfolio</a:t>
             </a:r>
           </a:p>
@@ -3988,8 +4076,8 @@
         </p:nvSpPr>
         <p:spPr>
           <a:xfrm>
-            <a:off x="457200" y="1371600"/>
-            <a:ext cx="8229600" cy="4572000"/>
+            <a:off x="1981201" y="1371600"/>
+            <a:ext cx="5321841" cy="3970318"/>
           </a:xfrm>
           <a:prstGeom prst="rect">
             <a:avLst/>
@@ -4013,6 +4101,7 @@
               </a:defRPr>
             </a:pPr>
             <a:r>
+              <a:rPr sz="2000"/>
               <a:t>• GPT-oss-20b</a:t>
             </a:r>
           </a:p>
@@ -4024,6 +4113,7 @@
               <a:defRPr sz="1400"/>
             </a:pPr>
             <a:r>
+              <a:rPr sz="1400"/>
               <a:t>  21B MoE (3.6B active), 128K context, Apache 2.0, L40 GPU</a:t>
             </a:r>
           </a:p>
@@ -4035,6 +4125,7 @@
               <a:defRPr sz="1400"/>
             </a:pPr>
             <a:r>
+              <a:rPr sz="1400"/>
               <a:t>  Use: Document parsing, reasoning</a:t>
             </a:r>
           </a:p>
@@ -4050,6 +4141,7 @@
               </a:defRPr>
             </a:pPr>
             <a:r>
+              <a:rPr sz="2000"/>
               <a:t>• BGE-M3</a:t>
             </a:r>
           </a:p>
@@ -4061,6 +4153,7 @@
               <a:defRPr sz="1400"/>
             </a:pPr>
             <a:r>
+              <a:rPr sz="1400"/>
               <a:t>  568M params, 1024-dim embeddings, Multilingual EN/HE, CPU</a:t>
             </a:r>
           </a:p>
@@ -4072,6 +4165,7 @@
               <a:defRPr sz="1400"/>
             </a:pPr>
             <a:r>
+              <a:rPr sz="1400"/>
               <a:t>  Use: Semantic search, RAG</a:t>
             </a:r>
           </a:p>
@@ -4087,6 +4181,7 @@
               </a:defRPr>
             </a:pPr>
             <a:r>
+              <a:rPr sz="2000"/>
               <a:t>• Qwen3-4B-Instruct</a:t>
             </a:r>
           </a:p>
@@ -4098,6 +4193,7 @@
               <a:defRPr sz="1400"/>
             </a:pPr>
             <a:r>
+              <a:rPr sz="1400"/>
               <a:t>  4B params, 131K context, Red Hat certified, L40 GPU</a:t>
             </a:r>
           </a:p>
@@ -4109,6 +4205,7 @@
               <a:defRPr sz="1400"/>
             </a:pPr>
             <a:r>
+              <a:rPr sz="1400"/>
               <a:t>  Use: Backup general tasks</a:t>
             </a:r>
           </a:p>
@@ -4124,6 +4221,7 @@
               </a:defRPr>
             </a:pPr>
             <a:r>
+              <a:rPr sz="2000"/>
               <a:t>• GPT-4o</a:t>
             </a:r>
           </a:p>
@@ -4135,6 +4233,7 @@
               <a:defRPr sz="1400"/>
             </a:pPr>
             <a:r>
+              <a:rPr sz="1400"/>
               <a:t>  OpenAI via MaaS proxy, Premium tier</a:t>
             </a:r>
           </a:p>
@@ -4146,6 +4245,7 @@
               <a:defRPr sz="1400"/>
             </a:pPr>
             <a:r>
+              <a:rPr sz="1400"/>
               <a:t>  Use: Complex tasks, fallback</a:t>
             </a:r>
           </a:p>
@@ -4160,7 +4260,7 @@
 </file>
 
 <file path=ppt/slides/slide5.xml><?xml version="1.0" encoding="utf-8"?>
-<p:sld xmlns:a="http://schemas.openxmlformats.org/drawingml/2006/main" xmlns:p="http://schemas.openxmlformats.org/presentationml/2006/main" xmlns:r="http://schemas.openxmlformats.org/officeDocument/2006/relationships">
+<p:sld xmlns:a="http://schemas.openxmlformats.org/drawingml/2006/main" xmlns:r="http://schemas.openxmlformats.org/officeDocument/2006/relationships" xmlns:p="http://schemas.openxmlformats.org/presentationml/2006/main">
   <p:cSld>
     <p:spTree>
       <p:nvGrpSpPr>
@@ -4168,7 +4268,14 @@
         <p:cNvGrpSpPr/>
         <p:nvPr/>
       </p:nvGrpSpPr>
-      <p:grpSpPr/>
+      <p:grpSpPr>
+        <a:xfrm>
+          <a:off x="0" y="0"/>
+          <a:ext cx="0" cy="0"/>
+          <a:chOff x="0" y="0"/>
+          <a:chExt cx="0" cy="0"/>
+        </a:xfrm>
+      </p:grpSpPr>
       <p:sp>
         <p:nvSpPr>
           <p:cNvPr id="2" name="TextBox 1"/>
@@ -4177,8 +4284,8 @@
         </p:nvSpPr>
         <p:spPr>
           <a:xfrm>
-            <a:off x="457200" y="274320"/>
-            <a:ext cx="8229600" cy="640080"/>
+            <a:off x="1981200" y="274321"/>
+            <a:ext cx="5151154" cy="584775"/>
           </a:xfrm>
           <a:prstGeom prst="rect">
             <a:avLst/>
@@ -4199,6 +4306,7 @@
               </a:defRPr>
             </a:pPr>
             <a:r>
+              <a:rPr sz="3200"/>
               <a:t>RAG with Vector Embeddings</a:t>
             </a:r>
           </a:p>
@@ -4212,8 +4320,8 @@
         </p:nvSpPr>
         <p:spPr>
           <a:xfrm>
-            <a:off x="457200" y="1371600"/>
-            <a:ext cx="8229600" cy="4572000"/>
+            <a:off x="1981200" y="1371601"/>
+            <a:ext cx="4705584" cy="4165243"/>
           </a:xfrm>
           <a:prstGeom prst="rect">
             <a:avLst/>
@@ -4233,6 +4341,7 @@
               <a:defRPr sz="1600"/>
             </a:pPr>
             <a:r>
+              <a:rPr sz="1600"/>
               <a:t>Hebrew ISO9001 Document Upload</a:t>
             </a:r>
           </a:p>
@@ -4244,6 +4353,7 @@
               <a:defRPr sz="1400"/>
             </a:pPr>
             <a:r>
+              <a:rPr sz="1400"/>
               <a:t>1. LLM Extraction (GPT-oss-20b, 128K context) → 94 clauses ✓</a:t>
             </a:r>
           </a:p>
@@ -4255,6 +4365,7 @@
               <a:defRPr sz="1400"/>
             </a:pPr>
             <a:r>
+              <a:rPr sz="1400"/>
               <a:t>2. Chunking (1000 chars, 100 overlap) → 123 chunks</a:t>
             </a:r>
           </a:p>
@@ -4266,6 +4377,7 @@
               <a:defRPr sz="1400"/>
             </a:pPr>
             <a:r>
+              <a:rPr sz="1400"/>
               <a:t>3. BGE-M3 Embedding (batch: 32) → 1024-dim vectors</a:t>
             </a:r>
           </a:p>
@@ -4277,6 +4389,7 @@
               <a:defRPr sz="1400"/>
             </a:pPr>
             <a:r>
+              <a:rPr sz="1400"/>
               <a:t>4. PostgreSQL + pgvector storage</a:t>
             </a:r>
           </a:p>
@@ -4288,6 +4401,7 @@
               <a:defRPr sz="1400"/>
             </a:pPr>
             <a:r>
+              <a:rPr sz="1400"/>
               <a:t>5. IVFFlat index (cosine similarity, 100 lists)</a:t>
             </a:r>
           </a:p>
@@ -4298,6 +4412,7 @@
               </a:spcAft>
               <a:defRPr sz="1400"/>
             </a:pPr>
+            <a:endParaRPr sz="1400"/>
           </a:p>
           <a:p>
             <a:pPr>
@@ -4307,6 +4422,7 @@
               <a:defRPr sz="1400"/>
             </a:pPr>
             <a:r>
+              <a:rPr sz="1400"/>
               <a:t>Query: 'quality management requirements'</a:t>
             </a:r>
           </a:p>
@@ -4318,6 +4434,7 @@
               <a:defRPr sz="1400"/>
             </a:pPr>
             <a:r>
+              <a:rPr sz="1400"/>
               <a:t>  → BGE-M3 embedding (1024-dim)</a:t>
             </a:r>
           </a:p>
@@ -4329,6 +4446,7 @@
               <a:defRPr sz="1400"/>
             </a:pPr>
             <a:r>
+              <a:rPr sz="1400"/>
               <a:t>  → Cosine similarity search</a:t>
             </a:r>
           </a:p>
@@ -4340,6 +4458,7 @@
               <a:defRPr sz="1400"/>
             </a:pPr>
             <a:r>
+              <a:rPr sz="1400"/>
               <a:t>  → Top-K relevant clauses (&lt;100ms)</a:t>
             </a:r>
           </a:p>
@@ -4350,6 +4469,7 @@
               </a:spcAft>
               <a:defRPr sz="1400"/>
             </a:pPr>
+            <a:endParaRPr sz="1400"/>
           </a:p>
           <a:p>
             <a:pPr>
@@ -4359,6 +4479,7 @@
               <a:defRPr sz="1400" b="1"/>
             </a:pPr>
             <a:r>
+              <a:rPr sz="1400"/>
               <a:t>Before RAG: 21 clauses (regex) ❌</a:t>
             </a:r>
           </a:p>
@@ -4370,6 +4491,7 @@
               <a:defRPr sz="1400" b="1"/>
             </a:pPr>
             <a:r>
+              <a:rPr sz="1400"/>
               <a:t>After RAG: 94 clauses (LLM) ✓</a:t>
             </a:r>
           </a:p>
@@ -4384,7 +4506,7 @@
 </file>
 
 <file path=ppt/slides/slide6.xml><?xml version="1.0" encoding="utf-8"?>
-<p:sld xmlns:a="http://schemas.openxmlformats.org/drawingml/2006/main" xmlns:p="http://schemas.openxmlformats.org/presentationml/2006/main" xmlns:r="http://schemas.openxmlformats.org/officeDocument/2006/relationships">
+<p:sld xmlns:a="http://schemas.openxmlformats.org/drawingml/2006/main" xmlns:r="http://schemas.openxmlformats.org/officeDocument/2006/relationships" xmlns:p="http://schemas.openxmlformats.org/presentationml/2006/main">
   <p:cSld>
     <p:spTree>
       <p:nvGrpSpPr>
@@ -4392,7 +4514,14 @@
         <p:cNvGrpSpPr/>
         <p:nvPr/>
       </p:nvGrpSpPr>
-      <p:grpSpPr/>
+      <p:grpSpPr>
+        <a:xfrm>
+          <a:off x="0" y="0"/>
+          <a:ext cx="0" cy="0"/>
+          <a:chOff x="0" y="0"/>
+          <a:chExt cx="0" cy="0"/>
+        </a:xfrm>
+      </p:grpSpPr>
       <p:sp>
         <p:nvSpPr>
           <p:cNvPr id="2" name="TextBox 1"/>
@@ -4401,8 +4530,8 @@
         </p:nvSpPr>
         <p:spPr>
           <a:xfrm>
-            <a:off x="457200" y="274320"/>
-            <a:ext cx="8229600" cy="640080"/>
+            <a:off x="1981201" y="274321"/>
+            <a:ext cx="6640151" cy="584775"/>
           </a:xfrm>
           <a:prstGeom prst="rect">
             <a:avLst/>
@@ -4423,6 +4552,7 @@
               </a:defRPr>
             </a:pPr>
             <a:r>
+              <a:rPr sz="3200"/>
               <a:t>Enterprise Security - Defense in Depth</a:t>
             </a:r>
           </a:p>
@@ -4436,8 +4566,8 @@
         </p:nvSpPr>
         <p:spPr>
           <a:xfrm>
-            <a:off x="457200" y="1371600"/>
-            <a:ext cx="8229600" cy="4572000"/>
+            <a:off x="1981201" y="1371600"/>
+            <a:ext cx="5022593" cy="2882840"/>
           </a:xfrm>
           <a:prstGeom prst="rect">
             <a:avLst/>
@@ -4472,6 +4602,7 @@
               <a:defRPr sz="1400"/>
             </a:pPr>
             <a:r>
+              <a:rPr sz="1400"/>
               <a:t>  OpenShift Routes (TLS), Google OAuth, JWT tokens</a:t>
             </a:r>
           </a:p>
@@ -4498,6 +4629,7 @@
               <a:defRPr sz="1400"/>
             </a:pPr>
             <a:r>
+              <a:rPr sz="1400"/>
               <a:t>  Kuadrant rate limiting, Authorino JWT validation, K8s RBAC</a:t>
             </a:r>
           </a:p>
@@ -4524,6 +4656,7 @@
               <a:defRPr sz="1400"/>
             </a:pPr>
             <a:r>
+              <a:rPr sz="1400"/>
               <a:t>  TrustyAI HAP detection, topic filtering, prompt validation</a:t>
             </a:r>
           </a:p>
@@ -4550,6 +4683,7 @@
               <a:defRPr sz="1400"/>
             </a:pPr>
             <a:r>
+              <a:rPr sz="1400"/>
               <a:t>  PostgreSQL row-level security, K8s Secrets, audit logging</a:t>
             </a:r>
           </a:p>
@@ -4564,7 +4698,7 @@
 </file>
 
 <file path=ppt/slides/slide7.xml><?xml version="1.0" encoding="utf-8"?>
-<p:sld xmlns:a="http://schemas.openxmlformats.org/drawingml/2006/main" xmlns:p="http://schemas.openxmlformats.org/presentationml/2006/main" xmlns:r="http://schemas.openxmlformats.org/officeDocument/2006/relationships">
+<p:sld xmlns:a="http://schemas.openxmlformats.org/drawingml/2006/main" xmlns:r="http://schemas.openxmlformats.org/officeDocument/2006/relationships" xmlns:p="http://schemas.openxmlformats.org/presentationml/2006/main">
   <p:cSld>
     <p:spTree>
       <p:nvGrpSpPr>
@@ -4572,7 +4706,14 @@
         <p:cNvGrpSpPr/>
         <p:nvPr/>
       </p:nvGrpSpPr>
-      <p:grpSpPr/>
+      <p:grpSpPr>
+        <a:xfrm>
+          <a:off x="0" y="0"/>
+          <a:ext cx="0" cy="0"/>
+          <a:chOff x="0" y="0"/>
+          <a:chExt cx="0" cy="0"/>
+        </a:xfrm>
+      </p:grpSpPr>
       <p:sp>
         <p:nvSpPr>
           <p:cNvPr id="2" name="TextBox 1"/>
@@ -4581,8 +4722,8 @@
         </p:nvSpPr>
         <p:spPr>
           <a:xfrm>
-            <a:off x="457200" y="274320"/>
-            <a:ext cx="8229600" cy="640080"/>
+            <a:off x="1981200" y="274321"/>
+            <a:ext cx="6253828" cy="584775"/>
           </a:xfrm>
           <a:prstGeom prst="rect">
             <a:avLst/>
@@ -4603,6 +4744,7 @@
               </a:defRPr>
             </a:pPr>
             <a:r>
+              <a:rPr sz="3200"/>
               <a:t>Model as a Service (MaaS) Gateway</a:t>
             </a:r>
           </a:p>
@@ -4616,8 +4758,8 @@
         </p:nvSpPr>
         <p:spPr>
           <a:xfrm>
-            <a:off x="457200" y="1371600"/>
-            <a:ext cx="8229600" cy="4572000"/>
+            <a:off x="1981200" y="1371600"/>
+            <a:ext cx="6568786" cy="3252172"/>
           </a:xfrm>
           <a:prstGeom prst="rect">
             <a:avLst/>
@@ -4641,6 +4783,7 @@
               </a:defRPr>
             </a:pPr>
             <a:r>
+              <a:rPr sz="2000"/>
               <a:t>Benefits:</a:t>
             </a:r>
           </a:p>
@@ -4652,6 +4795,7 @@
               <a:defRPr sz="1600"/>
             </a:pPr>
             <a:r>
+              <a:rPr sz="1600"/>
               <a:t>✓ Unified OpenAI-compatible /v1 API</a:t>
             </a:r>
           </a:p>
@@ -4663,6 +4807,7 @@
               <a:defRPr sz="1600"/>
             </a:pPr>
             <a:r>
+              <a:rPr sz="1600"/>
               <a:t>✓ Multi-tenancy with per-user rate limiting</a:t>
             </a:r>
           </a:p>
@@ -4674,6 +4819,7 @@
               <a:defRPr sz="1600"/>
             </a:pPr>
             <a:r>
+              <a:rPr sz="1600"/>
               <a:t>✓ Full observability (TrustyAI logs all requests)</a:t>
             </a:r>
           </a:p>
@@ -4685,6 +4831,7 @@
               <a:defRPr sz="1600"/>
             </a:pPr>
             <a:r>
+              <a:rPr sz="1600"/>
               <a:t>✓ Security: JWT validation + RBAC enforcement</a:t>
             </a:r>
           </a:p>
@@ -4696,6 +4843,7 @@
               <a:defRPr sz="1600"/>
             </a:pPr>
             <a:r>
+              <a:rPr sz="1600"/>
               <a:t>✓ Flexibility: Route to on-prem or cloud models</a:t>
             </a:r>
           </a:p>
@@ -4705,6 +4853,7 @@
                 <a:spcPts val="800"/>
               </a:spcAft>
             </a:pPr>
+            <a:endParaRPr/>
           </a:p>
           <a:p>
             <a:pPr>
@@ -4718,6 +4867,7 @@
               </a:defRPr>
             </a:pPr>
             <a:r>
+              <a:rPr sz="2000"/>
               <a:t>Components:</a:t>
             </a:r>
           </a:p>
@@ -4726,6 +4876,7 @@
               <a:defRPr sz="1400"/>
             </a:pPr>
             <a:r>
+              <a:rPr sz="1400"/>
               <a:t>Kuadrant (API mgmt) → Authorino (auth) → TrustyAI (observability) → vLLM (inference)</a:t>
             </a:r>
           </a:p>
@@ -4740,7 +4891,7 @@
 </file>
 
 <file path=ppt/slides/slide8.xml><?xml version="1.0" encoding="utf-8"?>
-<p:sld xmlns:a="http://schemas.openxmlformats.org/drawingml/2006/main" xmlns:p="http://schemas.openxmlformats.org/presentationml/2006/main" xmlns:r="http://schemas.openxmlformats.org/officeDocument/2006/relationships">
+<p:sld xmlns:a="http://schemas.openxmlformats.org/drawingml/2006/main" xmlns:r="http://schemas.openxmlformats.org/officeDocument/2006/relationships" xmlns:p="http://schemas.openxmlformats.org/presentationml/2006/main">
   <p:cSld>
     <p:spTree>
       <p:nvGrpSpPr>
@@ -4748,7 +4899,14 @@
         <p:cNvGrpSpPr/>
         <p:nvPr/>
       </p:nvGrpSpPr>
-      <p:grpSpPr/>
+      <p:grpSpPr>
+        <a:xfrm>
+          <a:off x="0" y="0"/>
+          <a:ext cx="0" cy="0"/>
+          <a:chOff x="0" y="0"/>
+          <a:chExt cx="0" cy="0"/>
+        </a:xfrm>
+      </p:grpSpPr>
       <p:sp>
         <p:nvSpPr>
           <p:cNvPr id="2" name="TextBox 1"/>
@@ -4757,8 +4915,8 @@
         </p:nvSpPr>
         <p:spPr>
           <a:xfrm>
-            <a:off x="457200" y="274320"/>
-            <a:ext cx="8229600" cy="640080"/>
+            <a:off x="1981200" y="274321"/>
+            <a:ext cx="3444726" cy="584775"/>
           </a:xfrm>
           <a:prstGeom prst="rect">
             <a:avLst/>
@@ -4779,6 +4937,7 @@
               </a:defRPr>
             </a:pPr>
             <a:r>
+              <a:rPr sz="3200"/>
               <a:t>Observability Stack</a:t>
             </a:r>
           </a:p>
@@ -4792,8 +4951,8 @@
         </p:nvSpPr>
         <p:spPr>
           <a:xfrm>
-            <a:off x="457200" y="1371600"/>
-            <a:ext cx="8229600" cy="4572000"/>
+            <a:off x="1981200" y="1371601"/>
+            <a:ext cx="4507388" cy="3400931"/>
           </a:xfrm>
           <a:prstGeom prst="rect">
             <a:avLst/>
@@ -4817,6 +4976,7 @@
               </a:defRPr>
             </a:pPr>
             <a:r>
+              <a:rPr sz="2000"/>
               <a:t>Grafana Dashboard: LLM Observability</a:t>
             </a:r>
           </a:p>
@@ -4828,6 +4988,7 @@
               <a:defRPr sz="1400"/>
             </a:pPr>
             <a:r>
+              <a:rPr sz="1400"/>
               <a:t>Request Rate: GPT-oss-20b (2.3 req/s), BGE-M3 (15.7 req/s)</a:t>
             </a:r>
           </a:p>
@@ -4839,6 +5000,7 @@
               <a:defRPr sz="1400"/>
             </a:pPr>
             <a:r>
+              <a:rPr sz="1400"/>
               <a:t>Latency: P95 2.3s (GPT-oss-20b), P95 45ms (BGE-M3)</a:t>
             </a:r>
           </a:p>
@@ -4850,6 +5012,7 @@
               <a:defRPr sz="1400"/>
             </a:pPr>
             <a:r>
+              <a:rPr sz="1400"/>
               <a:t>GPU Utilization: Cache 87%, Memory 42GB/48GB</a:t>
             </a:r>
           </a:p>
@@ -4861,6 +5024,7 @@
               <a:defRPr sz="1400"/>
             </a:pPr>
             <a:r>
+              <a:rPr sz="1400"/>
               <a:t>Model Health: All models ✓ UP</a:t>
             </a:r>
           </a:p>
@@ -4871,6 +5035,7 @@
               </a:spcAft>
               <a:defRPr sz="1400"/>
             </a:pPr>
+            <a:endParaRPr sz="1400"/>
           </a:p>
           <a:p>
             <a:pPr>
@@ -4880,6 +5045,7 @@
               <a:defRPr sz="1400" b="1"/>
             </a:pPr>
             <a:r>
+              <a:rPr sz="1400"/>
               <a:t>Components:</a:t>
             </a:r>
           </a:p>
@@ -4891,6 +5057,7 @@
               <a:defRPr sz="1400"/>
             </a:pPr>
             <a:r>
+              <a:rPr sz="1400"/>
               <a:t>• Prometheus: vLLM metrics, KServe metrics</a:t>
             </a:r>
           </a:p>
@@ -4902,6 +5069,7 @@
               <a:defRPr sz="1400"/>
             </a:pPr>
             <a:r>
+              <a:rPr sz="1400"/>
               <a:t>• Grafana: Custom LLM dashboard</a:t>
             </a:r>
           </a:p>
@@ -4913,6 +5081,7 @@
               <a:defRPr sz="1400"/>
             </a:pPr>
             <a:r>
+              <a:rPr sz="1400"/>
               <a:t>• TrustyAI: Request/response logging</a:t>
             </a:r>
           </a:p>
@@ -4924,6 +5093,7 @@
               <a:defRPr sz="1400"/>
             </a:pPr>
             <a:r>
+              <a:rPr sz="1400"/>
               <a:t>• ServiceMonitors: All LLM endpoints</a:t>
             </a:r>
           </a:p>
@@ -4938,7 +5108,7 @@
 </file>
 
 <file path=ppt/slides/slide9.xml><?xml version="1.0" encoding="utf-8"?>
-<p:sld xmlns:a="http://schemas.openxmlformats.org/drawingml/2006/main" xmlns:p="http://schemas.openxmlformats.org/presentationml/2006/main" xmlns:r="http://schemas.openxmlformats.org/officeDocument/2006/relationships">
+<p:sld xmlns:a="http://schemas.openxmlformats.org/drawingml/2006/main" xmlns:r="http://schemas.openxmlformats.org/officeDocument/2006/relationships" xmlns:p="http://schemas.openxmlformats.org/presentationml/2006/main">
   <p:cSld>
     <p:spTree>
       <p:nvGrpSpPr>
@@ -4946,7 +5116,14 @@
         <p:cNvGrpSpPr/>
         <p:nvPr/>
       </p:nvGrpSpPr>
-      <p:grpSpPr/>
+      <p:grpSpPr>
+        <a:xfrm>
+          <a:off x="0" y="0"/>
+          <a:ext cx="0" cy="0"/>
+          <a:chOff x="0" y="0"/>
+          <a:chExt cx="0" cy="0"/>
+        </a:xfrm>
+      </p:grpSpPr>
       <p:sp>
         <p:nvSpPr>
           <p:cNvPr id="2" name="TextBox 1"/>
@@ -4955,8 +5132,8 @@
         </p:nvSpPr>
         <p:spPr>
           <a:xfrm>
-            <a:off x="457200" y="274320"/>
-            <a:ext cx="8229600" cy="640080"/>
+            <a:off x="1981201" y="274321"/>
+            <a:ext cx="4874027" cy="584775"/>
           </a:xfrm>
           <a:prstGeom prst="rect">
             <a:avLst/>
@@ -4977,6 +5154,7 @@
               </a:defRPr>
             </a:pPr>
             <a:r>
+              <a:rPr sz="3200"/>
               <a:t>GitOps 4-Layer Deployment</a:t>
             </a:r>
           </a:p>
@@ -4990,8 +5168,8 @@
         </p:nvSpPr>
         <p:spPr>
           <a:xfrm>
-            <a:off x="457200" y="1371600"/>
-            <a:ext cx="8229600" cy="4572000"/>
+            <a:off x="1981201" y="1371601"/>
+            <a:ext cx="5802999" cy="3477875"/>
           </a:xfrm>
           <a:prstGeom prst="rect">
             <a:avLst/>
@@ -5026,6 +5204,7 @@
               <a:defRPr sz="1400"/>
             </a:pPr>
             <a:r>
+              <a:rPr sz="1400"/>
               <a:t>  Namespaces, RBAC, RHOAI config</a:t>
             </a:r>
           </a:p>
@@ -5052,6 +5231,7 @@
               <a:defRPr sz="1400"/>
             </a:pPr>
             <a:r>
+              <a:rPr sz="1400"/>
               <a:t>  PostgreSQL, Redis, pgvector migration</a:t>
             </a:r>
           </a:p>
@@ -5078,6 +5258,7 @@
               <a:defRPr sz="1400"/>
             </a:pPr>
             <a:r>
+              <a:rPr sz="1400"/>
               <a:t>  iso-api, iso-web, doc-agents, playground</a:t>
             </a:r>
           </a:p>
@@ -5104,6 +5285,7 @@
               <a:defRPr sz="1400"/>
             </a:pPr>
             <a:r>
+              <a:rPr sz="1400"/>
               <a:t>  Git clone + LFS + BGE-M3 embedding generation</a:t>
             </a:r>
           </a:p>
@@ -5113,12 +5295,14 @@
                 <a:spcPts val="800"/>
               </a:spcAft>
             </a:pPr>
+            <a:endParaRPr/>
           </a:p>
           <a:p>
             <a:pPr>
               <a:defRPr sz="1400" b="1"/>
             </a:pPr>
             <a:r>
+              <a:rPr sz="1400"/>
               <a:t>Benefits: Declarative · Auditable · Auto-sync · Rollback-capable · Sync waves</a:t>
             </a:r>
           </a:p>

</xml_diff>